<commit_message>
Slides: name the Progressing condition and its reason (sd-13-017), answer both migration cases (sd-13-020)
Co-Authored-By: Claude Sonnet 5.5 <noreply@anthropic.com>
Claude-Session: https://claude.ai/code/session_01EhxTYrCJpuk4mcqCLwPdds
</commit_message>
<xml_diff>
--- a/system-design-101/vi/lessons/sd-13-017/slides/sd-13-017.pptx
+++ b/system-design-101/vi/lessons/sd-13-017/slides/sd-13-017.pptx
@@ -7197,7 +7197,7 @@
               <a:t> hạn</a:t>
             </a:r>
             <a:r>
-              <a:rPr lang="en-US" sz="3300" dirty="0" spc="-2" kern="0">
+              <a:rPr lang="en-US" sz="3300" dirty="0" spc="-3" kern="0">
                 <a:solidFill>
                   <a:srgbClr val="14161C"/>
                 </a:solidFill>
@@ -7205,10 +7205,10 @@
                 <a:ea typeface="Be Vietnam Pro SemiBold" pitchFamily="34" charset="-122"/>
                 <a:cs typeface="Be Vietnam Pro SemiBold" pitchFamily="34" charset="-120"/>
               </a:rPr>
-              <a:t> chỉ</a:t>
-            </a:r>
-            <a:r>
-              <a:rPr lang="en-US" sz="3300" dirty="0" spc="-5" kern="0">
+              <a:t> thì</a:t>
+            </a:r>
+            <a:r>
+              <a:rPr lang="en-US" sz="3300" dirty="0" spc="23" kern="0">
                 <a:solidFill>
                   <a:srgbClr val="14161C"/>
                 </a:solidFill>
@@ -7216,10 +7216,10 @@
                 <a:ea typeface="Be Vietnam Pro SemiBold" pitchFamily="34" charset="-122"/>
                 <a:cs typeface="Be Vietnam Pro SemiBold" pitchFamily="34" charset="-120"/>
               </a:rPr>
-              <a:t> thêm</a:t>
-            </a:r>
-            <a:r>
-              <a:rPr lang="en-US" sz="3300" dirty="0" spc="23" kern="0">
+              <a:t> điều</a:t>
+            </a:r>
+            <a:r>
+              <a:rPr lang="en-US" sz="3300" dirty="0" spc="-2" kern="0">
                 <a:solidFill>
                   <a:srgbClr val="14161C"/>
                 </a:solidFill>
@@ -7227,10 +7227,10 @@
                 <a:ea typeface="Be Vietnam Pro SemiBold" pitchFamily="34" charset="-122"/>
                 <a:cs typeface="Be Vietnam Pro SemiBold" pitchFamily="34" charset="-120"/>
               </a:rPr>
-              <a:t> điều</a:t>
-            </a:r>
-            <a:r>
-              <a:rPr lang="en-US" sz="3300" dirty="0" spc="-2" kern="0">
+              <a:t> kiện</a:t>
+            </a:r>
+            <a:r>
+              <a:rPr lang="en-US" sz="3300" dirty="0" spc="-20" kern="0">
                 <a:solidFill>
                   <a:srgbClr val="14161C"/>
                 </a:solidFill>
@@ -7238,7 +7238,40 @@
                 <a:ea typeface="Be Vietnam Pro SemiBold" pitchFamily="34" charset="-122"/>
                 <a:cs typeface="Be Vietnam Pro SemiBold" pitchFamily="34" charset="-120"/>
               </a:rPr>
-              <a:t> kiện</a:t>
+              <a:t> Progressing</a:t>
+            </a:r>
+            <a:r>
+              <a:rPr lang="en-US" sz="3300" dirty="0" spc="-5" kern="0">
+                <a:solidFill>
+                  <a:srgbClr val="14161C"/>
+                </a:solidFill>
+                <a:latin typeface="Be Vietnam Pro SemiBold" pitchFamily="34" charset="0"/>
+                <a:ea typeface="Be Vietnam Pro SemiBold" pitchFamily="34" charset="-122"/>
+                <a:cs typeface="Be Vietnam Pro SemiBold" pitchFamily="34" charset="-120"/>
+              </a:rPr>
+              <a:t> có</a:t>
+            </a:r>
+            <a:r>
+              <a:rPr lang="en-US" sz="3300" dirty="0" spc="1" kern="0">
+                <a:solidFill>
+                  <a:srgbClr val="14161C"/>
+                </a:solidFill>
+                <a:latin typeface="Be Vietnam Pro SemiBold" pitchFamily="34" charset="0"/>
+                <a:ea typeface="Be Vietnam Pro SemiBold" pitchFamily="34" charset="-122"/>
+                <a:cs typeface="Be Vietnam Pro SemiBold" pitchFamily="34" charset="-120"/>
+              </a:rPr>
+              <a:t> lý</a:t>
+            </a:r>
+            <a:r>
+              <a:rPr lang="en-US" sz="3300" dirty="0" spc="-6" kern="0">
+                <a:solidFill>
+                  <a:srgbClr val="14161C"/>
+                </a:solidFill>
+                <a:latin typeface="Be Vietnam Pro SemiBold" pitchFamily="34" charset="0"/>
+                <a:ea typeface="Be Vietnam Pro SemiBold" pitchFamily="34" charset="-122"/>
+                <a:cs typeface="Be Vietnam Pro SemiBold" pitchFamily="34" charset="-120"/>
+              </a:rPr>
+              <a:t> do</a:t>
             </a:r>
             <a:r>
               <a:rPr lang="en-US" sz="3300" dirty="0" spc="-16" kern="0">

</xml_diff>

<commit_message>
Slides: say that terminating Pods can lift the total above four (sd-13-017)
Co-Authored-By: Claude Sonnet 5.5 <noreply@anthropic.com>
Claude-Session: https://claude.ai/code/session_01EhxTYrCJpuk4mcqCLwPdds
</commit_message>
<xml_diff>
--- a/system-design-101/vi/lessons/sd-13-017/slides/sd-13-017.pptx
+++ b/system-design-101/vi/lessons/sd-13-017/slides/sd-13-017.pptx
@@ -10444,7 +10444,7 @@
               <a:buNone/>
             </a:pPr>
             <a:r>
-              <a:rPr lang="en-US" sz="3900" dirty="0" spc="-42" kern="0">
+              <a:rPr lang="en-US" sz="3900" dirty="0" spc="-137" kern="0">
                 <a:solidFill>
                   <a:srgbClr val="F3EEE3"/>
                 </a:solidFill>
@@ -10452,10 +10452,10 @@
                 <a:ea typeface="Be Vietnam Pro ExtraBold" pitchFamily="34" charset="-122"/>
                 <a:cs typeface="Be Vietnam Pro ExtraBold" pitchFamily="34" charset="-120"/>
               </a:rPr>
-              <a:t>Pod</a:t>
-            </a:r>
-            <a:r>
-              <a:rPr lang="en-US" sz="3900" dirty="0" spc="-5" kern="0">
+              <a:t>Tối</a:t>
+            </a:r>
+            <a:r>
+              <a:rPr lang="en-US" sz="3900" dirty="0" spc="3" kern="0">
                 <a:solidFill>
                   <a:srgbClr val="F3EEE3"/>
                 </a:solidFill>
@@ -10463,10 +10463,10 @@
                 <a:ea typeface="Be Vietnam Pro ExtraBold" pitchFamily="34" charset="-122"/>
                 <a:cs typeface="Be Vietnam Pro ExtraBold" pitchFamily="34" charset="-120"/>
               </a:rPr>
-              <a:t> tối</a:t>
-            </a:r>
-            <a:r>
-              <a:rPr lang="en-US" sz="3900" dirty="0" spc="3" kern="0">
+              <a:t> đa</a:t>
+            </a:r>
+            <a:r>
+              <a:rPr lang="en-US" sz="3900" dirty="0" spc="-15" kern="0">
                 <a:solidFill>
                   <a:srgbClr val="F3EEE3"/>
                 </a:solidFill>
@@ -10474,10 +10474,10 @@
                 <a:ea typeface="Be Vietnam Pro ExtraBold" pitchFamily="34" charset="-122"/>
                 <a:cs typeface="Be Vietnam Pro ExtraBold" pitchFamily="34" charset="-120"/>
               </a:rPr>
-              <a:t> đa</a:t>
-            </a:r>
-            <a:r>
-              <a:rPr lang="en-US" sz="3900" dirty="0" spc="-15" kern="0">
+              <a:t> không</a:t>
+            </a:r>
+            <a:r>
+              <a:rPr lang="en-US" sz="3900" dirty="0" spc="1" kern="0">
                 <a:solidFill>
                   <a:srgbClr val="F3EEE3"/>
                 </a:solidFill>
@@ -10485,10 +10485,10 @@
                 <a:ea typeface="Be Vietnam Pro ExtraBold" pitchFamily="34" charset="-122"/>
                 <a:cs typeface="Be Vietnam Pro ExtraBold" pitchFamily="34" charset="-120"/>
               </a:rPr>
-              <a:t> không</a:t>
-            </a:r>
-            <a:r>
-              <a:rPr lang="en-US" sz="3900" dirty="0" spc="1" kern="0">
+              <a:t> đang</a:t>
+            </a:r>
+            <a:r>
+              <a:rPr lang="en-US" sz="3900" dirty="0" spc="-9" kern="0">
                 <a:solidFill>
                   <a:srgbClr val="F3EEE3"/>
                 </a:solidFill>
@@ -10496,10 +10496,10 @@
                 <a:ea typeface="Be Vietnam Pro ExtraBold" pitchFamily="34" charset="-122"/>
                 <a:cs typeface="Be Vietnam Pro ExtraBold" pitchFamily="34" charset="-120"/>
               </a:rPr>
-              <a:t> đang</a:t>
-            </a:r>
-            <a:r>
-              <a:rPr lang="en-US" sz="3900" dirty="0" spc="-11" kern="0">
+              <a:t> tắt:</a:t>
+            </a:r>
+            <a:r>
+              <a:rPr lang="en-US" sz="3900" dirty="0" spc="1" kern="0">
                 <a:solidFill>
                   <a:srgbClr val="F3EEE3"/>
                 </a:solidFill>
@@ -10507,7 +10507,51 @@
                 <a:ea typeface="Be Vietnam Pro ExtraBold" pitchFamily="34" charset="-122"/>
                 <a:cs typeface="Be Vietnam Pro ExtraBold" pitchFamily="34" charset="-120"/>
               </a:rPr>
-              <a:t> tắt</a:t>
+              <a:t> 3</a:t>
+            </a:r>
+            <a:r>
+              <a:rPr lang="en-US" sz="3900" dirty="0" spc="-3" kern="0">
+                <a:solidFill>
+                  <a:srgbClr val="F3EEE3"/>
+                </a:solidFill>
+                <a:latin typeface="Be Vietnam Pro ExtraBold" pitchFamily="34" charset="0"/>
+                <a:ea typeface="Be Vietnam Pro ExtraBold" pitchFamily="34" charset="-122"/>
+                <a:cs typeface="Be Vietnam Pro ExtraBold" pitchFamily="34" charset="-120"/>
+              </a:rPr>
+              <a:t> +</a:t>
+            </a:r>
+            <a:r>
+              <a:rPr lang="en-US" sz="3900" dirty="0" spc="-1" kern="0">
+                <a:solidFill>
+                  <a:srgbClr val="F3EEE3"/>
+                </a:solidFill>
+                <a:latin typeface="Be Vietnam Pro ExtraBold" pitchFamily="34" charset="0"/>
+                <a:ea typeface="Be Vietnam Pro ExtraBold" pitchFamily="34" charset="-122"/>
+                <a:cs typeface="Be Vietnam Pro ExtraBold" pitchFamily="34" charset="-120"/>
+              </a:rPr>
+              <a:t> 1</a:t>
+            </a:r>
+            <a:r>
+              <a:rPr lang="en-US" sz="3900" dirty="0" spc="-2" kern="0">
+                <a:solidFill>
+                  <a:srgbClr val="F3EEE3"/>
+                </a:solidFill>
+                <a:latin typeface="Be Vietnam Pro ExtraBold" pitchFamily="34" charset="0"/>
+                <a:ea typeface="Be Vietnam Pro ExtraBold" pitchFamily="34" charset="-122"/>
+                <a:cs typeface="Be Vietnam Pro ExtraBold" pitchFamily="34" charset="-120"/>
+              </a:rPr>
+              <a:t> tạm</a:t>
+            </a:r>
+            <a:r>
+              <a:rPr lang="en-US" sz="3900" dirty="0" spc="1" kern="0">
+                <a:solidFill>
+                  <a:srgbClr val="F3EEE3"/>
+                </a:solidFill>
+                <a:latin typeface="Be Vietnam Pro ExtraBold" pitchFamily="34" charset="0"/>
+                <a:ea typeface="Be Vietnam Pro ExtraBold" pitchFamily="34" charset="-122"/>
+                <a:cs typeface="Be Vietnam Pro ExtraBold" pitchFamily="34" charset="-120"/>
+              </a:rPr>
+              <a:t> thời</a:t>
             </a:r>
             <a:endParaRPr lang="en-US" sz="3900" dirty="0"/>
           </a:p>
@@ -10538,7 +10582,7 @@
               <a:buNone/>
             </a:pPr>
             <a:r>
-              <a:rPr lang="en-US" sz="3000" dirty="0" spc="5" kern="0">
+              <a:rPr lang="en-US" sz="3000" dirty="0" spc="-24" kern="0">
                 <a:solidFill>
                   <a:srgbClr val="E4E1D8"/>
                 </a:solidFill>
@@ -10546,7 +10590,29 @@
                 <a:ea typeface="Be Vietnam Pro" pitchFamily="34" charset="-122"/>
                 <a:cs typeface="Be Vietnam Pro" pitchFamily="34" charset="-120"/>
               </a:rPr>
-              <a:t>3</a:t>
+              <a:t>Pod</a:t>
+            </a:r>
+            <a:r>
+              <a:rPr lang="en-US" sz="3000" dirty="0" spc="12" kern="0">
+                <a:solidFill>
+                  <a:srgbClr val="E4E1D8"/>
+                </a:solidFill>
+                <a:latin typeface="Be Vietnam Pro" pitchFamily="34" charset="0"/>
+                <a:ea typeface="Be Vietnam Pro" pitchFamily="34" charset="-122"/>
+                <a:cs typeface="Be Vietnam Pro" pitchFamily="34" charset="-120"/>
+              </a:rPr>
+              <a:t> đang</a:t>
+            </a:r>
+            <a:r>
+              <a:rPr lang="en-US" sz="3000" dirty="0" spc="-32" kern="0">
+                <a:solidFill>
+                  <a:srgbClr val="E4E1D8"/>
+                </a:solidFill>
+                <a:latin typeface="Be Vietnam Pro" pitchFamily="34" charset="0"/>
+                <a:ea typeface="Be Vietnam Pro" pitchFamily="34" charset="-122"/>
+                <a:cs typeface="Be Vietnam Pro" pitchFamily="34" charset="-120"/>
+              </a:rPr>
+              <a:t> tắt</a:t>
             </a:r>
             <a:r>
               <a:rPr lang="en-US" sz="3000" dirty="0" spc="1" kern="0">
@@ -10557,10 +10623,10 @@
                 <a:ea typeface="Be Vietnam Pro" pitchFamily="34" charset="-122"/>
                 <a:cs typeface="Be Vietnam Pro" pitchFamily="34" charset="-120"/>
               </a:rPr>
-              <a:t> +</a:t>
-            </a:r>
-            <a:r>
-              <a:rPr lang="en-US" sz="3000" dirty="0" spc="3" kern="0">
+              <a:t> không</a:t>
+            </a:r>
+            <a:r>
+              <a:rPr lang="en-US" sz="3000" dirty="0" spc="-1" kern="0">
                 <a:solidFill>
                   <a:srgbClr val="E4E1D8"/>
                 </a:solidFill>
@@ -10568,10 +10634,10 @@
                 <a:ea typeface="Be Vietnam Pro" pitchFamily="34" charset="-122"/>
                 <a:cs typeface="Be Vietnam Pro" pitchFamily="34" charset="-120"/>
               </a:rPr>
-              <a:t> 1</a:t>
-            </a:r>
-            <a:r>
-              <a:rPr lang="en-US" sz="3000" dirty="0" spc="-15" kern="0">
+              <a:t> tính;</a:t>
+            </a:r>
+            <a:r>
+              <a:rPr lang="en-US" sz="3000" dirty="0" spc="-12" kern="0">
                 <a:solidFill>
                   <a:srgbClr val="E4E1D8"/>
                 </a:solidFill>
@@ -10579,7 +10645,40 @@
                 <a:ea typeface="Be Vietnam Pro" pitchFamily="34" charset="-122"/>
                 <a:cs typeface="Be Vietnam Pro" pitchFamily="34" charset="-120"/>
               </a:rPr>
-              <a:t> tạm</a:t>
+              <a:t> tổng</a:t>
+            </a:r>
+            <a:r>
+              <a:rPr lang="en-US" sz="3000" dirty="0" spc="4" kern="0">
+                <a:solidFill>
+                  <a:srgbClr val="E4E1D8"/>
+                </a:solidFill>
+                <a:latin typeface="Be Vietnam Pro" pitchFamily="34" charset="0"/>
+                <a:ea typeface="Be Vietnam Pro" pitchFamily="34" charset="-122"/>
+                <a:cs typeface="Be Vietnam Pro" pitchFamily="34" charset="-120"/>
+              </a:rPr>
+              <a:t> có</a:t>
+            </a:r>
+            <a:r>
+              <a:rPr lang="en-US" sz="3000" dirty="0" spc="0" kern="0">
+                <a:solidFill>
+                  <a:srgbClr val="E4E1D8"/>
+                </a:solidFill>
+                <a:latin typeface="Be Vietnam Pro" pitchFamily="34" charset="0"/>
+                <a:ea typeface="Be Vietnam Pro" pitchFamily="34" charset="-122"/>
+                <a:cs typeface="Be Vietnam Pro" pitchFamily="34" charset="-120"/>
+              </a:rPr>
+              <a:t> thể</a:t>
+            </a:r>
+            <a:r>
+              <a:rPr lang="en-US" sz="3000" dirty="0" spc="-1" kern="0">
+                <a:solidFill>
+                  <a:srgbClr val="E4E1D8"/>
+                </a:solidFill>
+                <a:latin typeface="Be Vietnam Pro" pitchFamily="34" charset="0"/>
+                <a:ea typeface="Be Vietnam Pro" pitchFamily="34" charset="-122"/>
+                <a:cs typeface="Be Vietnam Pro" pitchFamily="34" charset="-120"/>
+              </a:rPr>
+              <a:t> hơn</a:t>
             </a:r>
             <a:r>
               <a:rPr lang="en-US" sz="3000" dirty="0" spc="1" kern="0">
@@ -10590,7 +10689,7 @@
                 <a:ea typeface="Be Vietnam Pro" pitchFamily="34" charset="-122"/>
                 <a:cs typeface="Be Vietnam Pro" pitchFamily="34" charset="-120"/>
               </a:rPr>
-              <a:t> thời.</a:t>
+              <a:t> 4.</a:t>
             </a:r>
             <a:endParaRPr lang="en-US" sz="3000" dirty="0"/>
           </a:p>

</xml_diff>